<commit_message>
Presentation v4.3: carry over the two wording edits from the Drive copy of v4.2
The team's Google Slides copy of v4.2 (edited 21 Oct) differs from the repo
deck in two on-screen places; its speaker notes match on every slide:
- slide 1 subtitle is the paper's title (now 20 pt, two lines);
- slide 8 caption: the 3 · 5 · 3 picks were "perceived equally as safe".

Co-Authored-By: Claude Opus 5.5 <noreply@anthropic.com>
</commit_message>
<xml_diff>
--- a/presentation/FYP-assessment-presentation-v4.3.pptx
+++ b/presentation/FYP-assessment-presentation-v4.3.pptx
@@ -7927,7 +7927,7 @@
           </a:ln>
         </p:spPr>
         <p:txBody>
-          <a:bodyPr xmlns:a="http://schemas.openxmlformats.org/drawingml/2006/main">
+          <a:bodyPr xmlns:a="http://schemas.openxmlformats.org/drawingml/2006/main" wrap="square">
             <a:noAutofit/>
           </a:bodyPr>
           <a:lstStyle xmlns:a="http://schemas.openxmlformats.org/drawingml/2006/main"/>
@@ -7943,7 +7943,7 @@
               </a:defRPr>
             </a:pPr>
             <a:r>
-              <a:rPr sz="2775" b="0">
+              <a:rPr sz="2000" b="0">
                 <a:solidFill>
                   <a:srgbClr val="006DAE"/>
                 </a:solidFill>
@@ -7951,7 +7951,7 @@
                 <a:ea typeface="Arial"/>
                 <a:cs typeface="Arial"/>
               </a:rPr>
-              <a:t>Keeping workers safe without stopping the robot for no reason</a:t>
+              <a:t>Safety and Efficiency of Context-Aware Speed and Separation Monitoring in Human–Robot Ceiling-Panel Installation</a:t>
             </a:r>
           </a:p>
         </p:txBody>
@@ -14059,7 +14059,7 @@
                 </a:solidFill>
                 <a:latin typeface="Arial"/>
               </a:rPr>
-              <a:t>times each controller was picked as 'safest': no better than chance</a:t>
+              <a:t>times each controller was picked as 'safest': perceived equally as safe</a:t>
             </a:r>
           </a:p>
         </p:txBody>

</xml_diff>

<commit_message>
Presentation v4.3: balance the title-slide subtitle, tidy slide 8 captions, update the guide
- Slide 1: the paper-title subtitle breaks after "Monitoring" so its two
  lines are even.
- Slide 8: curly quotes on 'safest'; "median time for the robot to stop
  (max 0.23 s)" now fits on one line instead of leaving "s)" alone.
- Guide: notes the two Drive edits carried into v4.3 and the slide 6 video
  label; the media section no longer says there is no video; the prepared
  handover lines now match the scripts.

Co-Authored-By: Claude Opus 5.5 <noreply@anthropic.com>
</commit_message>
<xml_diff>
--- a/presentation/FYP-assessment-presentation-v4.3.pptx
+++ b/presentation/FYP-assessment-presentation-v4.3.pptx
@@ -7951,7 +7951,19 @@
                 <a:ea typeface="Arial"/>
                 <a:cs typeface="Arial"/>
               </a:rPr>
-              <a:t>Safety and Efficiency of Context-Aware Speed and Separation Monitoring in Human–Robot Ceiling-Panel Installation</a:t>
+              <a:t>Safety and Efficiency of Context-Aware Speed and Separation Monitoring</a:t>
+            </a:r>
+            <a:br/>
+            <a:r>
+              <a:rPr sz="2000" b="0">
+                <a:solidFill>
+                  <a:srgbClr val="006DAE"/>
+                </a:solidFill>
+                <a:latin typeface="Arial"/>
+                <a:ea typeface="Arial"/>
+                <a:cs typeface="Arial"/>
+              </a:rPr>
+              <a:t>in Human–Robot Ceiling-Panel Installation</a:t>
             </a:r>
           </a:p>
         </p:txBody>
@@ -14059,7 +14071,7 @@
                 </a:solidFill>
                 <a:latin typeface="Arial"/>
               </a:rPr>
-              <a:t>times each controller was picked as 'safest': perceived equally as safe</a:t>
+              <a:t>times each controller was picked as ‘safest’: perceived equally as safe</a:t>
             </a:r>
           </a:p>
         </p:txBody>
@@ -14129,7 +14141,7 @@
                 </a:solidFill>
                 <a:latin typeface="Arial"/>
               </a:rPr>
-              <a:t>median time for the robot to actually stop (max 0.23 s)</a:t>
+              <a:t>median time for the robot to stop (max 0.23 s)</a:t>
             </a:r>
           </a:p>
         </p:txBody>

</xml_diff>

<commit_message>
Presentation v4.3: bigger, easier-to-read images on slides 2, 4 and 6
- Slide 2: the site photo and our lab photo sit side by side as 3.5 in
  squares (the lab photo was 1.5 in tall); the points are spaced by line
  count and the question box ends above the footer band.
- Slide 4: the console is recaptured at a narrow window on its ready card
  (the old capture read "0/5 systems ready" and "Robot control is switched
  off"), with a thin border; the model chart is redrawn at its slide size
  so its labels read at 16 pt.
- Slide 6: one large rig photo beside the video in place of two small ones;
  the play label moves off the participant; captions reworded so no word
  sits alone.

Co-Authored-By: Claude Opus 5.5 <noreply@anthropic.com>
</commit_message>
<xml_diff>
--- a/presentation/FYP-assessment-presentation-v4.3.pptx
+++ b/presentation/FYP-assessment-presentation-v4.3.pptx
@@ -1410,7 +1410,7 @@
           <a:p/>
           <a:p>
             <a:r>
-              <a:t>Installing ceiling panels requires workers to hold heavy boards overhead. On a typical site, shown here, one person simply holds the board while another fixes it. In our laboratory, below, a collaborative robot does the holding.</a:t>
+              <a:t>Installing ceiling panels requires workers to hold heavy boards overhead. On a typical site, on the left, one person simply holds the board while another fixes it. In our laboratory, beside it, a collaborative robot does the holding.</a:t>
             </a:r>
           </a:p>
           <a:p/>
@@ -10414,7 +10414,7 @@
         </p:nvSpPr>
         <p:spPr>
           <a:xfrm>
-            <a:off x="5349240" y="1371600"/>
+            <a:off x="7680960" y="1307592"/>
             <a:ext cx="502920" cy="502920"/>
           </a:xfrm>
           <a:prstGeom prst="ellipse">
@@ -10467,8 +10467,8 @@
         </p:nvSpPr>
         <p:spPr>
           <a:xfrm>
-            <a:off x="6035040" y="1325880"/>
-            <a:ext cx="5669280" cy="1188720"/>
+            <a:off x="8275320" y="1280160"/>
+            <a:ext cx="3337560" cy="1188720"/>
           </a:xfrm>
           <a:prstGeom prst="rect">
             <a:avLst/>
@@ -10483,7 +10483,7 @@
           <a:p>
             <a:pPr algn="l"/>
             <a:r>
-              <a:rPr sz="1900" b="1">
+              <a:rPr sz="1600" b="1">
                 <a:solidFill>
                   <a:srgbClr val="172D3D"/>
                 </a:solidFill>
@@ -10499,13 +10499,13 @@
               </a:spcBef>
             </a:pPr>
             <a:r>
-              <a:rPr sz="1900" b="0">
+              <a:rPr sz="1600" b="0">
                 <a:solidFill>
                   <a:srgbClr val="172D3D"/>
                 </a:solidFill>
                 <a:latin typeface="Arial"/>
               </a:rPr>
-              <a:t>A robot can hold the panel while the worker does the skilled part.</a:t>
+              <a:t>A robot can take the weight.</a:t>
             </a:r>
           </a:p>
         </p:txBody>
@@ -10518,7 +10518,7 @@
         </p:nvSpPr>
         <p:spPr>
           <a:xfrm>
-            <a:off x="5349240" y="2606039"/>
+            <a:off x="7680960" y="2606039"/>
             <a:ext cx="502920" cy="502920"/>
           </a:xfrm>
           <a:prstGeom prst="ellipse">
@@ -10571,8 +10571,8 @@
         </p:nvSpPr>
         <p:spPr>
           <a:xfrm>
-            <a:off x="6035040" y="2560320"/>
-            <a:ext cx="5669280" cy="1188720"/>
+            <a:off x="8275320" y="2578608"/>
+            <a:ext cx="3337560" cy="1188720"/>
           </a:xfrm>
           <a:prstGeom prst="rect">
             <a:avLst/>
@@ -10587,7 +10587,7 @@
           <a:p>
             <a:pPr algn="l"/>
             <a:r>
-              <a:rPr sz="1900" b="1">
+              <a:rPr sz="1600" b="1">
                 <a:solidFill>
                   <a:srgbClr val="172D3D"/>
                 </a:solidFill>
@@ -10603,13 +10603,13 @@
               </a:spcBef>
             </a:pPr>
             <a:r>
-              <a:rPr sz="1900" b="0">
+              <a:rPr sz="1600" b="0">
                 <a:solidFill>
                   <a:srgbClr val="172D3D"/>
                 </a:solidFill>
                 <a:latin typeface="Arial"/>
               </a:rPr>
-              <a:t>Safety zones stop the robot whenever someone is close.</a:t>
+              <a:t>Safety zones stop it whenever someone is close.</a:t>
             </a:r>
           </a:p>
         </p:txBody>
@@ -10622,7 +10622,7 @@
         </p:nvSpPr>
         <p:spPr>
           <a:xfrm>
-            <a:off x="5349240" y="3840480"/>
+            <a:off x="7680960" y="4151376"/>
             <a:ext cx="502920" cy="502920"/>
           </a:xfrm>
           <a:prstGeom prst="ellipse">
@@ -10675,8 +10675,8 @@
         </p:nvSpPr>
         <p:spPr>
           <a:xfrm>
-            <a:off x="6035040" y="3794760"/>
-            <a:ext cx="5669280" cy="1188720"/>
+            <a:off x="8275320" y="4123944"/>
+            <a:ext cx="3337560" cy="1188720"/>
           </a:xfrm>
           <a:prstGeom prst="rect">
             <a:avLst/>
@@ -10691,13 +10691,23 @@
           <a:p>
             <a:pPr algn="l"/>
             <a:r>
-              <a:rPr sz="1900" b="1">
+              <a:rPr sz="1600" b="1">
                 <a:solidFill>
                   <a:srgbClr val="172D3D"/>
                 </a:solidFill>
                 <a:latin typeface="Arial"/>
               </a:rPr>
-              <a:t>Stop too late: injury.  Stop too often: no one uses it.</a:t>
+              <a:t>Stop too late: injury.</a:t>
+            </a:r>
+            <a:br/>
+            <a:r>
+              <a:rPr sz="1600" b="1">
+                <a:solidFill>
+                  <a:srgbClr val="172D3D"/>
+                </a:solidFill>
+                <a:latin typeface="Arial"/>
+              </a:rPr>
+              <a:t>Stop too often: no one uses it.</a:t>
             </a:r>
           </a:p>
           <a:p>
@@ -10707,13 +10717,13 @@
               </a:spcBef>
             </a:pPr>
             <a:r>
-              <a:rPr sz="1900" b="0">
+              <a:rPr sz="1600" b="0">
                 <a:solidFill>
                   <a:srgbClr val="172D3D"/>
                 </a:solidFill>
                 <a:latin typeface="Arial"/>
               </a:rPr>
-              <a:t>Crews and contractors need it right both ways.</a:t>
+              <a:t>Crews need it right both ways.</a:t>
             </a:r>
           </a:p>
         </p:txBody>
@@ -10726,8 +10736,8 @@
         </p:nvSpPr>
         <p:spPr>
           <a:xfrm>
-            <a:off x="5349240" y="5120640"/>
-            <a:ext cx="6355080" cy="731520"/>
+            <a:off x="548640" y="5175504"/>
+            <a:ext cx="11155680" cy="694944"/>
           </a:xfrm>
           <a:prstGeom prst="roundRect">
             <a:avLst>
@@ -10772,8 +10782,8 @@
         </p:nvSpPr>
         <p:spPr>
           <a:xfrm>
-            <a:off x="5486400" y="5148072"/>
-            <a:ext cx="6126480" cy="685800"/>
+            <a:off x="685800" y="5193792"/>
+            <a:ext cx="10881360" cy="658368"/>
           </a:xfrm>
           <a:prstGeom prst="rect">
             <a:avLst/>
@@ -10788,7 +10798,7 @@
           <a:p>
             <a:pPr algn="l"/>
             <a:r>
-              <a:rPr sz="1600" b="1">
+              <a:rPr sz="1800" b="1">
                 <a:solidFill>
                   <a:srgbClr val="FFFFFF"/>
                 </a:solidFill>
@@ -10797,7 +10807,7 @@
               <a:t>Our question: </a:t>
             </a:r>
             <a:r>
-              <a:rPr sz="1600" b="0">
+              <a:rPr sz="1800" b="0">
                 <a:solidFill>
                   <a:srgbClr val="FFFFFF"/>
                 </a:solidFill>
@@ -10818,15 +10828,15 @@
         </p:nvPicPr>
         <p:blipFill>
           <a:blip r:embed="rId4"/>
-          <a:srcRect t="3003" b="9399"/>
+          <a:srcRect l="27734" r="3320" t="7833"/>
           <a:stretch>
             <a:fillRect/>
           </a:stretch>
         </p:blipFill>
         <p:spPr>
           <a:xfrm>
-            <a:off x="548640" y="1325880"/>
-            <a:ext cx="4187952" cy="2744253"/>
+            <a:off x="548640" y="1188720"/>
+            <a:ext cx="3200400" cy="3200400"/>
           </a:xfrm>
           <a:prstGeom prst="rect">
             <a:avLst/>
@@ -10835,60 +10845,14 @@
       </p:pic>
       <p:sp>
         <p:nvSpPr>
-          <p:cNvPr id="14" name="Rounded Rectangle 13"/>
-          <p:cNvSpPr/>
+          <p:cNvPr id="14" name="TextBox 13"/>
+          <p:cNvSpPr txBox="1"/>
           <p:nvPr/>
         </p:nvSpPr>
         <p:spPr>
           <a:xfrm>
-            <a:off x="658368" y="1435608"/>
-            <a:ext cx="1600200" cy="347472"/>
-          </a:xfrm>
-          <a:prstGeom prst="roundRect">
-            <a:avLst>
-              <a:gd name="adj" fmla="val 8000"/>
-            </a:avLst>
-          </a:prstGeom>
-          <a:solidFill>
-            <a:srgbClr val="172D3D"/>
-          </a:solidFill>
-          <a:ln>
-            <a:noFill/>
-          </a:ln>
-          <a:effectLst/>
-        </p:spPr>
-        <p:style>
-          <a:lnRef idx="1">
-            <a:schemeClr val="accent1"/>
-          </a:lnRef>
-          <a:fillRef idx="3">
-            <a:schemeClr val="accent1"/>
-          </a:fillRef>
-          <a:effectRef idx="2">
-            <a:schemeClr val="accent1"/>
-          </a:effectRef>
-          <a:fontRef idx="minor">
-            <a:schemeClr val="lt1"/>
-          </a:fontRef>
-        </p:style>
-        <p:txBody>
-          <a:bodyPr rtlCol="0" anchor="ctr"/>
-          <a:lstStyle/>
-          <a:p>
-            <a:pPr algn="ctr"/>
-          </a:p>
-        </p:txBody>
-      </p:sp>
-      <p:sp>
-        <p:nvSpPr>
-          <p:cNvPr id="15" name="TextBox 14"/>
-          <p:cNvSpPr txBox="1"/>
-          <p:nvPr/>
-        </p:nvSpPr>
-        <p:spPr>
-          <a:xfrm>
-            <a:off x="713232" y="1463040"/>
-            <a:ext cx="1508760" cy="310896"/>
+            <a:off x="548640" y="4462272"/>
+            <a:ext cx="3200400" cy="640080"/>
           </a:xfrm>
           <a:prstGeom prst="rect">
             <a:avLst/>
@@ -10903,107 +10867,13 @@
           <a:p>
             <a:pPr algn="l"/>
             <a:r>
-              <a:rPr sz="1300" b="1">
-                <a:solidFill>
-                  <a:srgbClr val="FFFFFF"/>
+              <a:rPr sz="1500" b="1">
+                <a:solidFill>
+                  <a:srgbClr val="006DAE"/>
                 </a:solidFill>
                 <a:latin typeface="Arial"/>
               </a:rPr>
               <a:t>On site today</a:t>
-            </a:r>
-          </a:p>
-        </p:txBody>
-      </p:sp>
-      <p:sp>
-        <p:nvSpPr>
-          <p:cNvPr id="16" name="TextBox 15"/>
-          <p:cNvSpPr txBox="1"/>
-          <p:nvPr/>
-        </p:nvSpPr>
-        <p:spPr>
-          <a:xfrm>
-            <a:off x="548640" y="4087368"/>
-            <a:ext cx="4187952" cy="201168"/>
-          </a:xfrm>
-          <a:prstGeom prst="rect">
-            <a:avLst/>
-          </a:prstGeom>
-          <a:noFill/>
-        </p:spPr>
-        <p:txBody>
-          <a:bodyPr wrap="square" anchor="t" lIns="45720" rIns="45720">
-            <a:spAutoFit/>
-          </a:bodyPr>
-          <a:lstStyle/>
-          <a:p>
-            <a:pPr algn="l"/>
-            <a:r>
-              <a:rPr sz="900" b="0">
-                <a:solidFill>
-                  <a:srgbClr val="536B79"/>
-                </a:solidFill>
-                <a:latin typeface="Arial"/>
-              </a:rPr>
-              <a:t>Photo: Qole Pejorian, CC BY 2.0</a:t>
-            </a:r>
-          </a:p>
-        </p:txBody>
-      </p:sp>
-      <p:pic>
-        <p:nvPicPr>
-          <p:cNvPr id="17" name="Picture 16" descr="image.jpg"/>
-          <p:cNvPicPr>
-            <a:picLocks noChangeAspect="1"/>
-          </p:cNvPicPr>
-          <p:nvPr/>
-        </p:nvPicPr>
-        <p:blipFill>
-          <a:blip r:embed="rId2"/>
-          <a:stretch>
-            <a:fillRect/>
-          </a:stretch>
-        </p:blipFill>
-        <p:spPr>
-          <a:xfrm>
-            <a:off x="548640" y="4343400"/>
-            <a:ext cx="1397000" cy="1508760"/>
-          </a:xfrm>
-          <a:prstGeom prst="rect">
-            <a:avLst/>
-          </a:prstGeom>
-        </p:spPr>
-      </p:pic>
-      <p:sp>
-        <p:nvSpPr>
-          <p:cNvPr id="18" name="TextBox 17"/>
-          <p:cNvSpPr txBox="1"/>
-          <p:nvPr/>
-        </p:nvSpPr>
-        <p:spPr>
-          <a:xfrm>
-            <a:off x="2103120" y="4343400"/>
-            <a:ext cx="2651760" cy="1508760"/>
-          </a:xfrm>
-          <a:prstGeom prst="rect">
-            <a:avLst/>
-          </a:prstGeom>
-          <a:noFill/>
-        </p:spPr>
-        <p:txBody>
-          <a:bodyPr wrap="square" anchor="ctr" lIns="45720" rIns="45720">
-            <a:spAutoFit/>
-          </a:bodyPr>
-          <a:lstStyle/>
-          <a:p>
-            <a:pPr algn="l"/>
-            <a:r>
-              <a:rPr sz="1500" b="1">
-                <a:solidFill>
-                  <a:srgbClr val="006DAE"/>
-                </a:solidFill>
-                <a:latin typeface="Arial"/>
-              </a:rPr>
-              <a:t>In our lab</a:t>
             </a:r>
           </a:p>
           <a:p>
@@ -11019,7 +10889,118 @@
                 </a:solidFill>
                 <a:latin typeface="Arial"/>
               </a:rPr>
-              <a:t>The robot holds the panel; the worker aligns and fixes it.</a:t>
+              <a:t>A second worker holds the board.</a:t>
+            </a:r>
+          </a:p>
+        </p:txBody>
+      </p:sp>
+      <p:pic>
+        <p:nvPicPr>
+          <p:cNvPr id="15" name="Picture 14" descr="image.jpg"/>
+          <p:cNvPicPr>
+            <a:picLocks noChangeAspect="1"/>
+          </p:cNvPicPr>
+          <p:nvPr/>
+        </p:nvPicPr>
+        <p:blipFill>
+          <a:blip r:embed="rId2"/>
+          <a:srcRect l="10000" b="16667"/>
+          <a:stretch>
+            <a:fillRect/>
+          </a:stretch>
+        </p:blipFill>
+        <p:spPr>
+          <a:xfrm>
+            <a:off x="3931920" y="1188720"/>
+            <a:ext cx="3200400" cy="3200400"/>
+          </a:xfrm>
+          <a:prstGeom prst="rect">
+            <a:avLst/>
+          </a:prstGeom>
+        </p:spPr>
+      </p:pic>
+      <p:sp>
+        <p:nvSpPr>
+          <p:cNvPr id="16" name="TextBox 15"/>
+          <p:cNvSpPr txBox="1"/>
+          <p:nvPr/>
+        </p:nvSpPr>
+        <p:spPr>
+          <a:xfrm>
+            <a:off x="3931920" y="4462272"/>
+            <a:ext cx="3200400" cy="640080"/>
+          </a:xfrm>
+          <a:prstGeom prst="rect">
+            <a:avLst/>
+          </a:prstGeom>
+          <a:noFill/>
+        </p:spPr>
+        <p:txBody>
+          <a:bodyPr wrap="square" anchor="t" lIns="45720" rIns="45720">
+            <a:spAutoFit/>
+          </a:bodyPr>
+          <a:lstStyle/>
+          <a:p>
+            <a:pPr algn="l"/>
+            <a:r>
+              <a:rPr sz="1500" b="1">
+                <a:solidFill>
+                  <a:srgbClr val="006DAE"/>
+                </a:solidFill>
+                <a:latin typeface="Arial"/>
+              </a:rPr>
+              <a:t>In our lab</a:t>
+            </a:r>
+          </a:p>
+          <a:p>
+            <a:pPr algn="l">
+              <a:spcBef>
+                <a:spcPts val="675"/>
+              </a:spcBef>
+            </a:pPr>
+            <a:r>
+              <a:rPr sz="1500" b="0">
+                <a:solidFill>
+                  <a:srgbClr val="172D3D"/>
+                </a:solidFill>
+                <a:latin typeface="Arial"/>
+              </a:rPr>
+              <a:t>The robot holds the panel.</a:t>
+            </a:r>
+          </a:p>
+        </p:txBody>
+      </p:sp>
+      <p:sp>
+        <p:nvSpPr>
+          <p:cNvPr id="17" name="TextBox 16"/>
+          <p:cNvSpPr txBox="1"/>
+          <p:nvPr/>
+        </p:nvSpPr>
+        <p:spPr>
+          <a:xfrm>
+            <a:off x="548640" y="4535424"/>
+            <a:ext cx="3200400" cy="201168"/>
+          </a:xfrm>
+          <a:prstGeom prst="rect">
+            <a:avLst/>
+          </a:prstGeom>
+          <a:noFill/>
+        </p:spPr>
+        <p:txBody>
+          <a:bodyPr wrap="square" anchor="t" lIns="45720" rIns="45720">
+            <a:spAutoFit/>
+          </a:bodyPr>
+          <a:lstStyle/>
+          <a:p>
+            <a:pPr algn="r"/>
+            <a:r>
+              <a:rPr sz="900" b="0">
+                <a:solidFill>
+                  <a:srgbClr val="536B79"/>
+                </a:solidFill>
+                <a:latin typeface="Arial"/>
+              </a:rPr>
+              <a:t>Photo: Qole Pejorian, CC BY 2.0</a:t>
             </a:r>
           </a:p>
         </p:txBody>
@@ -11943,56 +11924,6 @@
           </a:p>
         </p:txBody>
       </p:sp>
-      <p:pic>
-        <p:nvPicPr>
-          <p:cNvPr id="3" name="Picture 2" descr="dashboard-participant.png"/>
-          <p:cNvPicPr>
-            <a:picLocks noChangeAspect="1"/>
-          </p:cNvPicPr>
-          <p:nvPr/>
-        </p:nvPicPr>
-        <p:blipFill>
-          <a:blip r:embed="rId2"/>
-          <a:srcRect l="10312" r="10312" b="23333"/>
-          <a:stretch>
-            <a:fillRect/>
-          </a:stretch>
-        </p:blipFill>
-        <p:spPr>
-          <a:xfrm>
-            <a:off x="548640" y="1280160"/>
-            <a:ext cx="5486400" cy="2980800"/>
-          </a:xfrm>
-          <a:prstGeom prst="rect">
-            <a:avLst/>
-          </a:prstGeom>
-        </p:spPr>
-      </p:pic>
-      <p:pic>
-        <p:nvPicPr>
-          <p:cNvPr id="4" name="Picture 3" descr="held-out-trial.png"/>
-          <p:cNvPicPr>
-            <a:picLocks noChangeAspect="1"/>
-          </p:cNvPicPr>
-          <p:nvPr/>
-        </p:nvPicPr>
-        <p:blipFill>
-          <a:blip r:embed="rId3"/>
-          <a:srcRect l="909" r="909" t="2143" b="2976"/>
-          <a:stretch>
-            <a:fillRect/>
-          </a:stretch>
-        </p:blipFill>
-        <p:spPr>
-          <a:xfrm>
-            <a:off x="6309360" y="1775240"/>
-            <a:ext cx="5394960" cy="1990640"/>
-          </a:xfrm>
-          <a:prstGeom prst="rect">
-            <a:avLst/>
-          </a:prstGeom>
-        </p:spPr>
-      </p:pic>
       <p:sp>
         <p:nvSpPr>
           <p:cNvPr id="5" name="TextBox 4"/>
@@ -12001,8 +11932,8 @@
         </p:nvSpPr>
         <p:spPr>
           <a:xfrm>
-            <a:off x="548640" y="4343400"/>
-            <a:ext cx="5486400" cy="1097280"/>
+            <a:off x="548640" y="4773168"/>
+            <a:ext cx="5534712" cy="1097280"/>
           </a:xfrm>
           <a:prstGeom prst="rect">
             <a:avLst/>
@@ -12052,8 +11983,8 @@
         </p:nvSpPr>
         <p:spPr>
           <a:xfrm>
-            <a:off x="6309360" y="4343400"/>
-            <a:ext cx="5394960" cy="1097280"/>
+            <a:off x="6537960" y="4773168"/>
+            <a:ext cx="5166360" cy="1097280"/>
           </a:xfrm>
           <a:prstGeom prst="rect">
             <a:avLst/>
@@ -12090,7 +12021,7 @@
                 </a:solidFill>
                 <a:latin typeface="Arial"/>
               </a:rPr>
-              <a:t>Top: what they were doing. Bottom: what the model said, live.</a:t>
+              <a:t>Upper bar: what they were doing. Lower bar: what the model said, live.</a:t>
             </a:r>
           </a:p>
         </p:txBody>
@@ -12103,7 +12034,7 @@
         </p:nvSpPr>
         <p:spPr>
           <a:xfrm>
-            <a:off x="548640" y="5440680"/>
+            <a:off x="548640" y="5669280"/>
             <a:ext cx="11064240" cy="457200"/>
           </a:xfrm>
           <a:prstGeom prst="rect">
@@ -12165,6 +12096,59 @@
           </a:p>
         </p:txBody>
       </p:sp>
+      <p:pic>
+        <p:nvPicPr>
+          <p:cNvPr id="9" name="Picture 8" descr="dashboard-console-ready.png"/>
+          <p:cNvPicPr>
+            <a:picLocks noChangeAspect="1"/>
+          </p:cNvPicPr>
+          <p:nvPr/>
+        </p:nvPicPr>
+        <p:blipFill>
+          <a:blip r:embed="rId5"/>
+          <a:stretch>
+            <a:fillRect/>
+          </a:stretch>
+        </p:blipFill>
+        <p:spPr>
+          <a:xfrm>
+            <a:off x="548640" y="1188720"/>
+            <a:ext cx="5534712" cy="3520440"/>
+          </a:xfrm>
+          <a:prstGeom prst="rect">
+            <a:avLst/>
+          </a:prstGeom>
+          <a:ln w="9525">
+            <a:solidFill>
+              <a:srgbClr val="536B79"/>
+            </a:solidFill>
+          </a:ln>
+        </p:spPr>
+      </p:pic>
+      <p:pic>
+        <p:nvPicPr>
+          <p:cNvPr id="10" name="Picture 9" descr="held-out-trial-slide.png"/>
+          <p:cNvPicPr>
+            <a:picLocks noChangeAspect="1"/>
+          </p:cNvPicPr>
+          <p:nvPr/>
+        </p:nvPicPr>
+        <p:blipFill>
+          <a:blip r:embed="rId6"/>
+          <a:stretch>
+            <a:fillRect/>
+          </a:stretch>
+        </p:blipFill>
+        <p:spPr>
+          <a:xfrm>
+            <a:off x="6537960" y="1188720"/>
+            <a:ext cx="5166360" cy="3520440"/>
+          </a:xfrm>
+          <a:prstGeom prst="rect">
+            <a:avLst/>
+          </a:prstGeom>
+        </p:spPr>
+      </p:pic>
     </p:spTree>
   </p:cSld>
   <p:clrMapOvr>
@@ -13106,38 +13090,15 @@
         </p:nvPicPr>
         <p:blipFill>
           <a:blip r:embed="rId2"/>
+          <a:srcRect l="28333" r="22750"/>
           <a:stretch>
             <a:fillRect/>
           </a:stretch>
         </p:blipFill>
         <p:spPr>
           <a:xfrm>
-            <a:off x="7726679" y="3593592"/>
-            <a:ext cx="4023360" cy="2263140"/>
-          </a:xfrm>
-          <a:prstGeom prst="rect">
-            <a:avLst/>
-          </a:prstGeom>
-        </p:spPr>
-      </p:pic>
-      <p:pic>
-        <p:nvPicPr>
-          <p:cNvPr id="5" name="Picture 4" descr="apparatus-b.jpg"/>
-          <p:cNvPicPr>
-            <a:picLocks noChangeAspect="1"/>
-          </p:cNvPicPr>
-          <p:nvPr/>
-        </p:nvPicPr>
-        <p:blipFill>
-          <a:blip r:embed="rId3"/>
-          <a:stretch>
-            <a:fillRect/>
-          </a:stretch>
-        </p:blipFill>
-        <p:spPr>
-          <a:xfrm>
             <a:off x="7726679" y="1234440"/>
-            <a:ext cx="4023360" cy="2259787"/>
+            <a:ext cx="4023360" cy="4626521"/>
           </a:xfrm>
           <a:prstGeom prst="rect">
             <a:avLst/>
@@ -13241,7 +13202,7 @@
                 </a:solidFill>
                 <a:latin typeface="Arial"/>
               </a:rPr>
-              <a:t>head position to about a millimetre</a:t>
+              <a:t>head position to about one millimetre</a:t>
             </a:r>
           </a:p>
         </p:txBody>
@@ -13292,7 +13253,7 @@
                 </a:solidFill>
                 <a:latin typeface="Arial"/>
               </a:rPr>
-              <a:t>positions of 23 body segments</a:t>
+              <a:t>tracks the motion of all 23 body segments</a:t>
             </a:r>
           </a:p>
         </p:txBody>
@@ -13373,7 +13334,7 @@
         </p:nvSpPr>
         <p:spPr>
           <a:xfrm>
-            <a:off x="658368" y="1344168"/>
+            <a:off x="4736592" y="4498848"/>
             <a:ext cx="2377440" cy="384048"/>
           </a:xfrm>
           <a:prstGeom prst="roundRect">
@@ -13419,7 +13380,7 @@
         </p:nvSpPr>
         <p:spPr>
           <a:xfrm>
-            <a:off x="713232" y="1371600"/>
+            <a:off x="4791456" y="4526280"/>
             <a:ext cx="2286000" cy="347472"/>
           </a:xfrm>
           <a:prstGeom prst="rect">

</xml_diff>

<commit_message>
Presentation v4.3: circle and label the OptiTrack camera, Xsens suit and UR10 arm on slide 6
Amber rings and arrows with navy labels point out each piece of hardware
on the rig photo, so the speaker can point at it as he names it.

Co-Authored-By: Claude Opus 5.5 <noreply@anthropic.com>
</commit_message>
<xml_diff>
--- a/presentation/FYP-assessment-presentation-v4.3.pptx
+++ b/presentation/FYP-assessment-presentation-v4.3.pptx
@@ -13407,6 +13407,509 @@
           </a:p>
         </p:txBody>
       </p:sp>
+      <p:sp>
+        <p:nvSpPr>
+          <p:cNvPr id="14" name="Oval 13"/>
+          <p:cNvSpPr/>
+          <p:nvPr/>
+        </p:nvSpPr>
+        <p:spPr>
+          <a:xfrm>
+            <a:off x="9748641" y="1611415"/>
+            <a:ext cx="274164" cy="274164"/>
+          </a:xfrm>
+          <a:prstGeom prst="ellipse">
+            <a:avLst/>
+          </a:prstGeom>
+          <a:noFill/>
+          <a:ln w="38100">
+            <a:solidFill>
+              <a:srgbClr val="FFB81C"/>
+            </a:solidFill>
+          </a:ln>
+          <a:effectLst/>
+        </p:spPr>
+        <p:style>
+          <a:lnRef idx="1">
+            <a:schemeClr val="accent1"/>
+          </a:lnRef>
+          <a:fillRef idx="3">
+            <a:schemeClr val="accent1"/>
+          </a:fillRef>
+          <a:effectRef idx="2">
+            <a:schemeClr val="accent1"/>
+          </a:effectRef>
+          <a:fontRef idx="minor">
+            <a:schemeClr val="lt1"/>
+          </a:fontRef>
+        </p:style>
+        <p:txBody>
+          <a:bodyPr rtlCol="0" anchor="ctr"/>
+          <a:lstStyle/>
+          <a:p>
+            <a:pPr algn="ctr"/>
+          </a:p>
+        </p:txBody>
+      </p:sp>
+      <p:cxnSp>
+        <p:nvCxnSpPr>
+          <p:cNvPr id="15" name="Connector 14"/>
+          <p:cNvCxnSpPr/>
+          <p:nvPr/>
+        </p:nvCxnSpPr>
+        <p:spPr>
+          <a:xfrm>
+            <a:off x="8869680" y="1662822"/>
+            <a:ext cx="879445" cy="74157"/>
+          </a:xfrm>
+          <a:prstGeom prst="line">
+            <a:avLst/>
+          </a:prstGeom>
+          <a:ln w="31750">
+            <a:solidFill>
+              <a:srgbClr val="FFB81C"/>
+            </a:solidFill>
+            <a:tailEnd type="triangle"/>
+          </a:ln>
+        </p:spPr>
+        <p:style>
+          <a:lnRef idx="2">
+            <a:schemeClr val="accent1"/>
+          </a:lnRef>
+          <a:fillRef idx="0">
+            <a:schemeClr val="accent1"/>
+          </a:fillRef>
+          <a:effectRef idx="1">
+            <a:schemeClr val="accent1"/>
+          </a:effectRef>
+          <a:fontRef idx="minor">
+            <a:schemeClr val="tx1"/>
+          </a:fontRef>
+        </p:style>
+      </p:cxnSp>
+      <p:sp>
+        <p:nvSpPr>
+          <p:cNvPr id="16" name="Rounded Rectangle 15"/>
+          <p:cNvSpPr/>
+          <p:nvPr/>
+        </p:nvSpPr>
+        <p:spPr>
+          <a:xfrm>
+            <a:off x="7818120" y="1325880"/>
+            <a:ext cx="1051560" cy="585216"/>
+          </a:xfrm>
+          <a:prstGeom prst="roundRect">
+            <a:avLst>
+              <a:gd name="adj" fmla="val 8000"/>
+            </a:avLst>
+          </a:prstGeom>
+          <a:solidFill>
+            <a:srgbClr val="172D3D"/>
+          </a:solidFill>
+          <a:ln>
+            <a:noFill/>
+          </a:ln>
+          <a:effectLst/>
+        </p:spPr>
+        <p:style>
+          <a:lnRef idx="1">
+            <a:schemeClr val="accent1"/>
+          </a:lnRef>
+          <a:fillRef idx="3">
+            <a:schemeClr val="accent1"/>
+          </a:fillRef>
+          <a:effectRef idx="2">
+            <a:schemeClr val="accent1"/>
+          </a:effectRef>
+          <a:fontRef idx="minor">
+            <a:schemeClr val="lt1"/>
+          </a:fontRef>
+        </p:style>
+        <p:txBody>
+          <a:bodyPr rtlCol="0" anchor="ctr"/>
+          <a:lstStyle/>
+          <a:p>
+            <a:pPr algn="ctr"/>
+          </a:p>
+        </p:txBody>
+      </p:sp>
+      <p:sp>
+        <p:nvSpPr>
+          <p:cNvPr id="17" name="TextBox 16"/>
+          <p:cNvSpPr txBox="1"/>
+          <p:nvPr/>
+        </p:nvSpPr>
+        <p:spPr>
+          <a:xfrm>
+            <a:off x="7818120" y="1325880"/>
+            <a:ext cx="1051560" cy="585216"/>
+          </a:xfrm>
+          <a:prstGeom prst="rect">
+            <a:avLst/>
+          </a:prstGeom>
+          <a:noFill/>
+        </p:spPr>
+        <p:txBody>
+          <a:bodyPr wrap="none" anchor="ctr" lIns="45720" rIns="45720">
+            <a:spAutoFit/>
+          </a:bodyPr>
+          <a:lstStyle/>
+          <a:p>
+            <a:pPr algn="ctr"/>
+            <a:r>
+              <a:rPr sz="1500" b="1">
+                <a:solidFill>
+                  <a:srgbClr val="FFFFFF"/>
+                </a:solidFill>
+                <a:latin typeface="Arial"/>
+              </a:rPr>
+              <a:t>OptiTrack</a:t>
+            </a:r>
+            <a:br/>
+            <a:r>
+              <a:rPr sz="1500" b="1">
+                <a:solidFill>
+                  <a:srgbClr val="FFFFFF"/>
+                </a:solidFill>
+                <a:latin typeface="Arial"/>
+              </a:rPr>
+              <a:t>camera</a:t>
+            </a:r>
+          </a:p>
+        </p:txBody>
+      </p:sp>
+      <p:sp>
+        <p:nvSpPr>
+          <p:cNvPr id="18" name="Oval 17"/>
+          <p:cNvSpPr/>
+          <p:nvPr/>
+        </p:nvSpPr>
+        <p:spPr>
+          <a:xfrm>
+            <a:off x="9769203" y="3516857"/>
+            <a:ext cx="712826" cy="712826"/>
+          </a:xfrm>
+          <a:prstGeom prst="ellipse">
+            <a:avLst/>
+          </a:prstGeom>
+          <a:noFill/>
+          <a:ln w="38100">
+            <a:solidFill>
+              <a:srgbClr val="FFB81C"/>
+            </a:solidFill>
+          </a:ln>
+          <a:effectLst/>
+        </p:spPr>
+        <p:style>
+          <a:lnRef idx="1">
+            <a:schemeClr val="accent1"/>
+          </a:lnRef>
+          <a:fillRef idx="3">
+            <a:schemeClr val="accent1"/>
+          </a:fillRef>
+          <a:effectRef idx="2">
+            <a:schemeClr val="accent1"/>
+          </a:effectRef>
+          <a:fontRef idx="minor">
+            <a:schemeClr val="lt1"/>
+          </a:fontRef>
+        </p:style>
+        <p:txBody>
+          <a:bodyPr rtlCol="0" anchor="ctr"/>
+          <a:lstStyle/>
+          <a:p>
+            <a:pPr algn="ctr"/>
+          </a:p>
+        </p:txBody>
+      </p:sp>
+      <p:cxnSp>
+        <p:nvCxnSpPr>
+          <p:cNvPr id="19" name="Connector 18"/>
+          <p:cNvCxnSpPr/>
+          <p:nvPr/>
+        </p:nvCxnSpPr>
+        <p:spPr>
+          <a:xfrm>
+            <a:off x="8915400" y="3819249"/>
+            <a:ext cx="854158" cy="38128"/>
+          </a:xfrm>
+          <a:prstGeom prst="line">
+            <a:avLst/>
+          </a:prstGeom>
+          <a:ln w="31750">
+            <a:solidFill>
+              <a:srgbClr val="FFB81C"/>
+            </a:solidFill>
+            <a:tailEnd type="triangle"/>
+          </a:ln>
+        </p:spPr>
+        <p:style>
+          <a:lnRef idx="2">
+            <a:schemeClr val="accent1"/>
+          </a:lnRef>
+          <a:fillRef idx="0">
+            <a:schemeClr val="accent1"/>
+          </a:fillRef>
+          <a:effectRef idx="1">
+            <a:schemeClr val="accent1"/>
+          </a:effectRef>
+          <a:fontRef idx="minor">
+            <a:schemeClr val="tx1"/>
+          </a:fontRef>
+        </p:style>
+      </p:cxnSp>
+      <p:sp>
+        <p:nvSpPr>
+          <p:cNvPr id="20" name="Rounded Rectangle 19"/>
+          <p:cNvSpPr/>
+          <p:nvPr/>
+        </p:nvSpPr>
+        <p:spPr>
+          <a:xfrm>
+            <a:off x="7818120" y="3611880"/>
+            <a:ext cx="1097280" cy="365760"/>
+          </a:xfrm>
+          <a:prstGeom prst="roundRect">
+            <a:avLst>
+              <a:gd name="adj" fmla="val 8000"/>
+            </a:avLst>
+          </a:prstGeom>
+          <a:solidFill>
+            <a:srgbClr val="172D3D"/>
+          </a:solidFill>
+          <a:ln>
+            <a:noFill/>
+          </a:ln>
+          <a:effectLst/>
+        </p:spPr>
+        <p:style>
+          <a:lnRef idx="1">
+            <a:schemeClr val="accent1"/>
+          </a:lnRef>
+          <a:fillRef idx="3">
+            <a:schemeClr val="accent1"/>
+          </a:fillRef>
+          <a:effectRef idx="2">
+            <a:schemeClr val="accent1"/>
+          </a:effectRef>
+          <a:fontRef idx="minor">
+            <a:schemeClr val="lt1"/>
+          </a:fontRef>
+        </p:style>
+        <p:txBody>
+          <a:bodyPr rtlCol="0" anchor="ctr"/>
+          <a:lstStyle/>
+          <a:p>
+            <a:pPr algn="ctr"/>
+          </a:p>
+        </p:txBody>
+      </p:sp>
+      <p:sp>
+        <p:nvSpPr>
+          <p:cNvPr id="21" name="TextBox 20"/>
+          <p:cNvSpPr txBox="1"/>
+          <p:nvPr/>
+        </p:nvSpPr>
+        <p:spPr>
+          <a:xfrm>
+            <a:off x="7818120" y="3611880"/>
+            <a:ext cx="1097280" cy="365760"/>
+          </a:xfrm>
+          <a:prstGeom prst="rect">
+            <a:avLst/>
+          </a:prstGeom>
+          <a:noFill/>
+        </p:spPr>
+        <p:txBody>
+          <a:bodyPr wrap="none" anchor="ctr" lIns="45720" rIns="45720">
+            <a:spAutoFit/>
+          </a:bodyPr>
+          <a:lstStyle/>
+          <a:p>
+            <a:pPr algn="ctr"/>
+            <a:r>
+              <a:rPr sz="1500" b="1">
+                <a:solidFill>
+                  <a:srgbClr val="FFFFFF"/>
+                </a:solidFill>
+                <a:latin typeface="Arial"/>
+              </a:rPr>
+              <a:t>Xsens suit</a:t>
+            </a:r>
+          </a:p>
+        </p:txBody>
+      </p:sp>
+      <p:sp>
+        <p:nvSpPr>
+          <p:cNvPr id="22" name="Oval 21"/>
+          <p:cNvSpPr/>
+          <p:nvPr/>
+        </p:nvSpPr>
+        <p:spPr>
+          <a:xfrm>
+            <a:off x="10125616" y="2461324"/>
+            <a:ext cx="548328" cy="548328"/>
+          </a:xfrm>
+          <a:prstGeom prst="ellipse">
+            <a:avLst/>
+          </a:prstGeom>
+          <a:noFill/>
+          <a:ln w="38100">
+            <a:solidFill>
+              <a:srgbClr val="FFB81C"/>
+            </a:solidFill>
+          </a:ln>
+          <a:effectLst/>
+        </p:spPr>
+        <p:style>
+          <a:lnRef idx="1">
+            <a:schemeClr val="accent1"/>
+          </a:lnRef>
+          <a:fillRef idx="3">
+            <a:schemeClr val="accent1"/>
+          </a:fillRef>
+          <a:effectRef idx="2">
+            <a:schemeClr val="accent1"/>
+          </a:effectRef>
+          <a:fontRef idx="minor">
+            <a:schemeClr val="lt1"/>
+          </a:fontRef>
+        </p:style>
+        <p:txBody>
+          <a:bodyPr rtlCol="0" anchor="ctr"/>
+          <a:lstStyle/>
+          <a:p>
+            <a:pPr algn="ctr"/>
+          </a:p>
+        </p:txBody>
+      </p:sp>
+      <p:cxnSp>
+        <p:nvCxnSpPr>
+          <p:cNvPr id="23" name="Connector 22"/>
+          <p:cNvCxnSpPr/>
+          <p:nvPr/>
+        </p:nvCxnSpPr>
+        <p:spPr>
+          <a:xfrm flipH="1" flipV="1">
+            <a:off x="10598753" y="2924105"/>
+            <a:ext cx="339694" cy="322015"/>
+          </a:xfrm>
+          <a:prstGeom prst="line">
+            <a:avLst/>
+          </a:prstGeom>
+          <a:ln w="31750">
+            <a:solidFill>
+              <a:srgbClr val="FFB81C"/>
+            </a:solidFill>
+            <a:tailEnd type="triangle"/>
+          </a:ln>
+        </p:spPr>
+        <p:style>
+          <a:lnRef idx="2">
+            <a:schemeClr val="accent1"/>
+          </a:lnRef>
+          <a:fillRef idx="0">
+            <a:schemeClr val="accent1"/>
+          </a:fillRef>
+          <a:effectRef idx="1">
+            <a:schemeClr val="accent1"/>
+          </a:effectRef>
+          <a:fontRef idx="minor">
+            <a:schemeClr val="tx1"/>
+          </a:fontRef>
+        </p:style>
+      </p:cxnSp>
+      <p:sp>
+        <p:nvSpPr>
+          <p:cNvPr id="24" name="Rounded Rectangle 23"/>
+          <p:cNvSpPr/>
+          <p:nvPr/>
+        </p:nvSpPr>
+        <p:spPr>
+          <a:xfrm>
+            <a:off x="10771632" y="3246120"/>
+            <a:ext cx="950976" cy="585216"/>
+          </a:xfrm>
+          <a:prstGeom prst="roundRect">
+            <a:avLst>
+              <a:gd name="adj" fmla="val 8000"/>
+            </a:avLst>
+          </a:prstGeom>
+          <a:solidFill>
+            <a:srgbClr val="172D3D"/>
+          </a:solidFill>
+          <a:ln>
+            <a:noFill/>
+          </a:ln>
+          <a:effectLst/>
+        </p:spPr>
+        <p:style>
+          <a:lnRef idx="1">
+            <a:schemeClr val="accent1"/>
+          </a:lnRef>
+          <a:fillRef idx="3">
+            <a:schemeClr val="accent1"/>
+          </a:fillRef>
+          <a:effectRef idx="2">
+            <a:schemeClr val="accent1"/>
+          </a:effectRef>
+          <a:fontRef idx="minor">
+            <a:schemeClr val="lt1"/>
+          </a:fontRef>
+        </p:style>
+        <p:txBody>
+          <a:bodyPr rtlCol="0" anchor="ctr"/>
+          <a:lstStyle/>
+          <a:p>
+            <a:pPr algn="ctr"/>
+          </a:p>
+        </p:txBody>
+      </p:sp>
+      <p:sp>
+        <p:nvSpPr>
+          <p:cNvPr id="25" name="TextBox 24"/>
+          <p:cNvSpPr txBox="1"/>
+          <p:nvPr/>
+        </p:nvSpPr>
+        <p:spPr>
+          <a:xfrm>
+            <a:off x="10771632" y="3246120"/>
+            <a:ext cx="950976" cy="585216"/>
+          </a:xfrm>
+          <a:prstGeom prst="rect">
+            <a:avLst/>
+          </a:prstGeom>
+          <a:noFill/>
+        </p:spPr>
+        <p:txBody>
+          <a:bodyPr wrap="none" anchor="ctr" lIns="45720" rIns="45720">
+            <a:spAutoFit/>
+          </a:bodyPr>
+          <a:lstStyle/>
+          <a:p>
+            <a:pPr algn="ctr"/>
+            <a:r>
+              <a:rPr sz="1500" b="1">
+                <a:solidFill>
+                  <a:srgbClr val="FFFFFF"/>
+                </a:solidFill>
+                <a:latin typeface="Arial"/>
+              </a:rPr>
+              <a:t>UR10</a:t>
+            </a:r>
+            <a:br/>
+            <a:r>
+              <a:rPr sz="1500" b="1">
+                <a:solidFill>
+                  <a:srgbClr val="FFFFFF"/>
+                </a:solidFill>
+                <a:latin typeface="Arial"/>
+              </a:rPr>
+              <a:t>robot arm</a:t>
+            </a:r>
+          </a:p>
+        </p:txBody>
+      </p:sp>
     </p:spTree>
   </p:cSld>
   <p:clrMapOvr>

</xml_diff>

<commit_message>
Presentation v4.3: carry the team's script edits from the Drive doc into the speaker notes
Michael's slides 5 and 6 and Luke's slides 9, 10 and 11 now read as the team
edited them in the Drive scripts doc on 21 Oct, and slide 4 drops its
contribution sentence as 6 and 10 did. Slide 11 stays without carbon. The
guide gives the new word counts (1,270 words, about 9:04; Luke 3:25) and
flags that no script now states each speaker's contribution.

Co-Authored-By: Claude Opus 5.5 <noreply@anthropic.com>
</commit_message>
<xml_diff>
--- a/presentation/FYP-assessment-presentation-v4.3.pptx
+++ b/presentation/FYP-assessment-presentation-v4.3.pptx
@@ -1164,7 +1164,27 @@
           <a:p/>
           <a:p>
             <a:r>
-              <a:t>Moving from the laboratory to a site introduces real constraints. For safety, this is a research prototype running on the robot's standard speed controls, not a certified safety function, and we would allow half a second to react. For cost, the cameras and suits require calibration, maintenance and training for every crew, weighed against the labour saved. For health, it removes overhead lifting from workers, and participants rated the suit as only mildly restrictive. Finally, crews must accept a robotic co-worker, and any site system must meet the relevant robot safety standards.</a:t>
+              <a:t>Moving from the laboratory to a site introduces real constraints.</a:t>
+            </a:r>
+          </a:p>
+          <a:p>
+            <a:r>
+              <a:t>For safety, this is a research prototype running on the robot's standard speed controls, not a certified safety function, and we would allow half a second to react.</a:t>
+            </a:r>
+          </a:p>
+          <a:p>
+            <a:r>
+              <a:t>For cost, the cameras and suits require calibration, maintenance and training for every crew, weighed against the labour saved.</a:t>
+            </a:r>
+          </a:p>
+          <a:p>
+            <a:r>
+              <a:t>For health, it removes overhead lifting from workers, and participants rated the suit as only mildly restrictive.</a:t>
+            </a:r>
+          </a:p>
+          <a:p>
+            <a:r>
+              <a:t>Finally, crews must accept a robotic co-worker, and any site system must meet the relevant robot safety standards.</a:t>
             </a:r>
           </a:p>
         </p:txBody>
@@ -1322,7 +1342,7 @@
           <a:p/>
           <a:p>
             <a:r>
-              <a:t>My contribution was the software. On the left is the operator console we developed to run each session. It verifies every sensor, assigns the controller, and records both the robot and the participant.</a:t>
+              <a:t>On the left is the operator console we developed to run each session. It verifies every sensor, assigns the controller, and records both the robot and the participant.</a:t>
             </a:r>
           </a:p>
           <a:p/>
@@ -1586,7 +1606,7 @@
           <a:p/>
           <a:p>
             <a:r>
-              <a:t>Our key methodological decision was to log every sensor input. This allowed us to replay all three controllers on identical movement data, much like three referees reviewing the same match footage, so any difference in outcome comes from the controller rather than the participant.</a:t>
+              <a:t>Our key decision here was to use all the sensor inputs. This allowed us to see the same movement data from all three controllers, so any difference in outcome comes from the controller rather than the participant.</a:t>
             </a:r>
           </a:p>
         </p:txBody>
@@ -1662,13 +1682,13 @@
           <a:p/>
           <a:p>
             <a:r>
-              <a:t>My main contribution was the physical setup: I positioned the robot and built the PVC pipe structure shown here.</a:t>
+              <a:t>We positioned the robot and built the PVC pipe structure shown here.</a:t>
             </a:r>
           </a:p>
           <a:p/>
           <a:p>
             <a:r>
-              <a:t>The UR10 arm raises a panel substitute to ceiling height and holds it while the participant works beneath it. Cameras on the frame track the participant's head to about one millimetre, and the motion-capture suit records 23 body segments. [Click the video.] This clip shows a participant approaching while the suit streams their movement to the controller. The controller reads these data about sixty times per second and sets the speed the robot is permitted to move at.</a:t>
+              <a:t>The UR10 arm raises a panel substitute to ceiling height and holds it while the participant works beneath it. Cameras on the frame track the participant's head, and the motion-capture suit records the individual body segments. [Click the video.] This clip shows a participant approaching while the suit streams their movement to the controller. The controller reads the data and sets the speed the robot is permitted to move at.</a:t>
             </a:r>
           </a:p>
         </p:txBody>
@@ -1914,7 +1934,7 @@
           <a:p/>
           <a:p>
             <a:r>
-              <a:t>Thank you, Michael. Our most important finding was not which controller was best. Under all three, the robot was stopped for about one third of every trial, because the task itself requires the worker to be inside the stop zone: to load the panel, to work beneath it and to unload it.</a:t>
+              <a:t>Thank you, Michael. Our most important finding was not which controller was best but rather that the bigger limit is the task itself, not our controller. Under all three controllers, the robot was stopped for about one third of every trial [as we can see here]. This is because the task itself requires the worker to be inside the stop zone: to load the panel, to work beneath it and to unload it.</a:t>
             </a:r>
           </a:p>
           <a:p/>
@@ -1996,13 +2016,48 @@
           <a:p/>
           <a:p>
             <a:r>
-              <a:t>My role was coordinating with the laboratory staff and our supervisors, Yihai and Will. We planned four stages: design and simulation in July, building and pilot testing the rig in August, twelve participant sessions in September, and analysis and writing in October.</a:t>
+              <a:t>We planned four stages:</a:t>
+            </a:r>
+          </a:p>
+          <a:p>
+            <a:r>
+              <a:t>In July we refined our design and tested our project in simulation,</a:t>
+            </a:r>
+          </a:p>
+          <a:p>
+            <a:r>
+              <a:t>In August, we built the rig and undertook pilot testing.</a:t>
+            </a:r>
+          </a:p>
+          <a:p>
+            <a:r>
+              <a:t>In September, we tested twelve participants across four sessions</a:t>
+            </a:r>
+          </a:p>
+          <a:p>
+            <a:r>
+              <a:t>and conducted analysis and review as we wrote our paper in October.</a:t>
             </a:r>
           </a:p>
           <a:p/>
           <a:p>
             <a:r>
-              <a:t>Three setbacks shaped the project. First, some sessions were restarted under a new participant ID, so we matched sessions to participants using the recorded data. Second, the distance reference changed midway through testing, so we analysed the two versions separately and replayed the exact code that had run. Third, our paper was initially too technical, so we rewrote it for a broader audience.</a:t>
+              <a:t>We faced three setbacks across the project.</a:t>
+            </a:r>
+          </a:p>
+          <a:p>
+            <a:r>
+              <a:t>First, due to connection issues we had multiple sessions that restarted under a new participant ID. We then had to manually analyse the sessions and match participants using the recorded data of dimensions, answers etc.</a:t>
+            </a:r>
+          </a:p>
+          <a:p>
+            <a:r>
+              <a:t>Second, during the first six participants, distance was measured from the worker’s head to a fixed reference above the robot base. For the final six, this changed to whole-body tracking relative to the moving tool centre point. To account for this, we analysed both versions separately and replayed the exact code used in each.</a:t>
+            </a:r>
+          </a:p>
+          <a:p>
+            <a:r>
+              <a:t>Third, our paper was initially too technical, so we rewrote it for a broader audience and finalised this with our supervisors.</a:t>
             </a:r>
           </a:p>
         </p:txBody>

</xml_diff>